<commit_message>
Document hyperparameter tuning in reports; add live demo link (reports, README, docs, decks)
</commit_message>
<xml_diff>
--- a/docs/Traffic_Oracle_Phase1_Presentation.pptx
+++ b/docs/Traffic_Oracle_Phase1_Presentation.pptx
@@ -126,14 +126,14 @@
   <p:extLst>
     <p:ext uri="{521415D9-36F7-43E2-AB2F-B90AF26B5E84}">
       <p14:sectionLst xmlns:p14="http://schemas.microsoft.com/office/powerpoint/2010/main">
-        <p14:section name="Opening" id="{e84c720e-a300-87c7-1dae-77eb83e135dd}">
+        <p14:section name="Opening" id="{f9bfdc53-f8b6-e889-d0cf-e4247aa51802}">
           <p14:sldIdLst>
             <p14:sldId id="256"/>
             <p14:sldId id="257"/>
             <p14:sldId id="258"/>
           </p14:sldIdLst>
         </p14:section>
-        <p14:section name="01 The data" id="{03546477-1714-a6a7-afde-19ab9918a23b}">
+        <p14:section name="01 The data" id="{28998732-2f47-7924-7aef-dd3d65bbe4d6}">
           <p14:sldIdLst>
             <p14:sldId id="259"/>
             <p14:sldId id="260"/>
@@ -143,14 +143,14 @@
             <p14:sldId id="264"/>
           </p14:sldIdLst>
         </p14:section>
-        <p14:section name="02 A fair fight" id="{be7f885d-0484-98de-468e-0f0aa8693e43}">
+        <p14:section name="02 A fair fight" id="{3e5098c7-b738-b4a9-ae86-fd5c79e38007}">
           <p14:sldIdLst>
             <p14:sldId id="265"/>
             <p14:sldId id="266"/>
             <p14:sldId id="267"/>
           </p14:sldIdLst>
         </p14:section>
-        <p14:section name="03 Trees" id="{1d92ffbe-54d5-a6ca-a3b8-baa7ef207ccb}">
+        <p14:section name="03 Trees" id="{062a8367-e926-9f3f-9306-c0ee994ec5a9}">
           <p14:sldIdLst>
             <p14:sldId id="268"/>
             <p14:sldId id="269"/>
@@ -159,7 +159,7 @@
             <p14:sldId id="272"/>
           </p14:sldIdLst>
         </p14:section>
-        <p14:section name="Closing" id="{59200047-bb66-4d39-303c-3c0a24fba5f2}">
+        <p14:section name="Closing" id="{400a7dd1-d3ee-27f4-6f3d-3d4267bec24c}">
           <p14:sldIdLst>
             <p14:sldId id="273"/>
             <p14:sldId id="274"/>
@@ -10563,7 +10563,7 @@
         <p:spPr>
           <a:xfrm>
             <a:off x="731520" y="3017520"/>
-            <a:ext cx="10058400" cy="1005840"/>
+            <a:ext cx="10058400" cy="1280160"/>
           </a:xfrm>
           <a:prstGeom prst="rect">
             <a:avLst/>
@@ -10613,6 +10613,20 @@
                 </a:solidFill>
               </a:rPr>
               <a:t>github.com/Pranav-Singh-Devloper/traffic-oracle</a:t>
+            </a:r>
+            <a:endParaRPr lang="en-US" sz="1800" dirty="0"/>
+          </a:p>
+          <a:p>
+            <a:pPr indent="0" marL="0">
+              <a:buNone/>
+            </a:pPr>
+            <a:r>
+              <a:rPr lang="en-US" sz="1800" b="1" dirty="0">
+                <a:solidFill>
+                  <a:schemeClr val="accent3"/>
+                </a:solidFill>
+              </a:rPr>
+              <a:t>Live demo: traffic-oracle.streamlit.app</a:t>
             </a:r>
             <a:endParaRPr lang="en-US" sz="1800" dirty="0"/>
           </a:p>

</xml_diff>